<commit_message>
Fix Hebrew text direction in genetics presentation
Viewers that ignore the OOXML rtl flag laid the Hebrew out at LTR base
direction, which threw sentence-final periods to the wrong edge of the
line and reordered Hebrew around embedded Latin words like DNA. Wrap
each Hebrew line in an explicit bidi embedding so the layout no longer
depends on the viewer's base-direction guess.

Co-Authored-By: Claude Fable 5 <noreply@anthropic.com>
Claude-Session: https://claude.ai/code/session_01MUTHX6kZxGdRMb5aBhhRxE
</commit_message>
<xml_diff>
--- a/genetics_students_presentation.pptx
+++ b/genetics_students_presentation.pptx
@@ -3040,7 +3040,7 @@
                 <a:ea typeface="Arial" pitchFamily="34" charset="-122"/>
                 <a:cs typeface="Arial" pitchFamily="34" charset="-120"/>
               </a:rPr>
-              <a:t>גנטיקה</a:t>
+              <a:t>‫גנטיקה‬</a:t>
             </a:r>
             <a:endParaRPr lang="he-IL" sz="7200" dirty="0"/>
           </a:p>
@@ -3079,7 +3079,7 @@
                 <a:ea typeface="Arial" pitchFamily="34" charset="-122"/>
                 <a:cs typeface="Arial" pitchFamily="34" charset="-120"/>
               </a:rPr>
-              <a:t>המסע אל הצופן הסודי של החיים</a:t>
+              <a:t>‫המסע אל הצופן הסודי של החיים‬</a:t>
             </a:r>
             <a:endParaRPr lang="he-IL" sz="2800" dirty="0"/>
           </a:p>
@@ -3118,7 +3118,7 @@
                 <a:ea typeface="Arial" pitchFamily="34" charset="-122"/>
                 <a:cs typeface="Arial" pitchFamily="34" charset="-120"/>
               </a:rPr>
-              <a:t>יחידת לימוד לתלמידים  •  מדעים</a:t>
+              <a:t>‫יחידת לימוד לתלמידים  •  מדעים‬</a:t>
             </a:r>
             <a:endParaRPr lang="he-IL" sz="1600" dirty="0"/>
           </a:p>
@@ -3272,7 +3272,7 @@
                 <a:ea typeface="Arial" pitchFamily="34" charset="-122"/>
                 <a:cs typeface="Arial" pitchFamily="34" charset="-120"/>
               </a:rPr>
-              <a:t>גנטיקה בעולם האמיתי</a:t>
+              <a:t>‫גנטיקה בעולם האמיתי‬</a:t>
             </a:r>
             <a:endParaRPr lang="he-IL" sz="3200" dirty="0"/>
           </a:p>
@@ -3382,7 +3382,7 @@
                 <a:ea typeface="Arial" pitchFamily="34" charset="-122"/>
                 <a:cs typeface="Arial" pitchFamily="34" charset="-120"/>
               </a:rPr>
-              <a:t>רפואה</a:t>
+              <a:t>‫רפואה‬</a:t>
             </a:r>
             <a:endParaRPr lang="he-IL" sz="1700" dirty="0"/>
           </a:p>
@@ -3421,7 +3421,7 @@
                 <a:ea typeface="Arial" pitchFamily="34" charset="-122"/>
                 <a:cs typeface="Arial" pitchFamily="34" charset="-120"/>
               </a:rPr>
-              <a:t>בדיקות גנטיות ותרופות שמותאמות בדיוק לחולה.</a:t>
+              <a:t>‫בדיקות גנטיות ותרופות שמותאמות בדיוק לחולה.‬</a:t>
             </a:r>
             <a:endParaRPr lang="he-IL" sz="1500" dirty="0"/>
           </a:p>
@@ -3531,7 +3531,7 @@
                 <a:ea typeface="Arial" pitchFamily="34" charset="-122"/>
                 <a:cs typeface="Arial" pitchFamily="34" charset="-120"/>
               </a:rPr>
-              <a:t>חקלאות</a:t>
+              <a:t>‫חקלאות‬</a:t>
             </a:r>
             <a:endParaRPr lang="he-IL" sz="1700" dirty="0"/>
           </a:p>
@@ -3570,7 +3570,7 @@
                 <a:ea typeface="Arial" pitchFamily="34" charset="-122"/>
                 <a:cs typeface="Arial" pitchFamily="34" charset="-120"/>
               </a:rPr>
-              <a:t>גידולים שעמידים למחלות, לחום וליובש.</a:t>
+              <a:t>‫גידולים שעמידים למחלות, לחום וליובש.‬</a:t>
             </a:r>
             <a:endParaRPr lang="he-IL" sz="1500" dirty="0"/>
           </a:p>
@@ -3680,7 +3680,7 @@
                 <a:ea typeface="Arial" pitchFamily="34" charset="-122"/>
                 <a:cs typeface="Arial" pitchFamily="34" charset="-120"/>
               </a:rPr>
-              <a:t>זיהוי פלילי</a:t>
+              <a:t>‫זיהוי פלילי‬</a:t>
             </a:r>
             <a:endParaRPr lang="he-IL" sz="1700" dirty="0"/>
           </a:p>
@@ -3719,7 +3719,7 @@
                 <a:ea typeface="Arial" pitchFamily="34" charset="-122"/>
                 <a:cs typeface="Arial" pitchFamily="34" charset="-120"/>
               </a:rPr>
-              <a:t>שערה אחת מהזירה מספיקה כדי לזהות אדם.</a:t>
+              <a:t>‫שערה אחת מהזירה מספיקה כדי לזהות אדם.‬</a:t>
             </a:r>
             <a:endParaRPr lang="he-IL" sz="1500" dirty="0"/>
           </a:p>
@@ -3829,7 +3829,7 @@
                 <a:ea typeface="Arial" pitchFamily="34" charset="-122"/>
                 <a:cs typeface="Arial" pitchFamily="34" charset="-120"/>
               </a:rPr>
-              <a:t>הנדסה גנטית</a:t>
+              <a:t>‫הנדסה גנטית‬</a:t>
             </a:r>
             <a:endParaRPr lang="he-IL" sz="1700" dirty="0"/>
           </a:p>
@@ -3868,7 +3868,7 @@
                 <a:ea typeface="Arial" pitchFamily="34" charset="-122"/>
                 <a:cs typeface="Arial" pitchFamily="34" charset="-120"/>
               </a:rPr>
-              <a:t>מדענים "עורכים" גנים, למשל כדי לייצר אינסולין לחולי סוכרת.</a:t>
+              <a:t>‫מדענים "עורכים" גנים, למשל כדי לייצר אינסולין לחולי סוכרת.‬</a:t>
             </a:r>
             <a:endParaRPr lang="he-IL" sz="1500" dirty="0"/>
           </a:p>
@@ -3907,7 +3907,7 @@
                 <a:ea typeface="Arial" pitchFamily="34" charset="-122"/>
                 <a:cs typeface="Arial" pitchFamily="34" charset="-120"/>
               </a:rPr>
-              <a:t>זה בדיוק החומר שמחכה לכם בתוצרים: תוכלו לבחור נושא מהעולם האמיתי ולחקור אותו לעומק.</a:t>
+              <a:t>‫זה בדיוק החומר שמחכה לכם בתוצרים: תוכלו לבחור נושא מהעולם האמיתי ולחקור אותו לעומק.‬</a:t>
             </a:r>
             <a:endParaRPr lang="he-IL" sz="1400" dirty="0"/>
           </a:p>
@@ -4017,7 +4017,7 @@
                 <a:ea typeface="Arial" pitchFamily="34" charset="-122"/>
                 <a:cs typeface="Arial" pitchFamily="34" charset="-120"/>
               </a:rPr>
-              <a:t>לוח הבחירה: אתם מחליטים!</a:t>
+              <a:t>‫לוח הבחירה: אתם מחליטים!‬</a:t>
             </a:r>
             <a:endParaRPr lang="he-IL" sz="3200" dirty="0"/>
           </a:p>
@@ -4056,7 +4056,7 @@
                 <a:ea typeface="Arial" pitchFamily="34" charset="-122"/>
                 <a:cs typeface="Arial" pitchFamily="34" charset="-120"/>
               </a:rPr>
-              <a:t>בחרו תוצר אחד שמציג את מה שלמדתם, ועבדו לפי המחוון שתקבלו</a:t>
+              <a:t>‫בחרו תוצר אחד שמציג את מה שלמדתם, ועבדו לפי המחוון שתקבלו‬</a:t>
             </a:r>
             <a:endParaRPr lang="he-IL" sz="1600" dirty="0"/>
           </a:p>
@@ -4166,7 +4166,7 @@
                 <a:ea typeface="Arial" pitchFamily="34" charset="-122"/>
                 <a:cs typeface="Arial" pitchFamily="34" charset="-120"/>
               </a:rPr>
-              <a:t>מצגת דיגיטלית</a:t>
+              <a:t>‫מצגת דיגיטלית‬</a:t>
             </a:r>
             <a:endParaRPr lang="he-IL" sz="1550" dirty="0"/>
           </a:p>
@@ -4205,7 +4205,7 @@
                 <a:ea typeface="Arial" pitchFamily="34" charset="-122"/>
                 <a:cs typeface="Arial" pitchFamily="34" charset="-120"/>
               </a:rPr>
-              <a:t>הידע שלכם בשקופיות ברורות ומעוצבות</a:t>
+              <a:t>‫הידע שלכם בשקופיות ברורות ומעוצבות‬</a:t>
             </a:r>
             <a:endParaRPr lang="he-IL" sz="1150" dirty="0"/>
           </a:p>
@@ -4315,7 +4315,7 @@
                 <a:ea typeface="Arial" pitchFamily="34" charset="-122"/>
                 <a:cs typeface="Arial" pitchFamily="34" charset="-120"/>
               </a:rPr>
-              <a:t>סרטון</a:t>
+              <a:t>‫סרטון‬</a:t>
             </a:r>
             <a:endParaRPr lang="he-IL" sz="1550" dirty="0"/>
           </a:p>
@@ -4354,7 +4354,7 @@
                 <a:ea typeface="Arial" pitchFamily="34" charset="-122"/>
                 <a:cs typeface="Arial" pitchFamily="34" charset="-120"/>
               </a:rPr>
-              <a:t>הסבר חזותי וקולי בקצב שלכם</a:t>
+              <a:t>‫הסבר חזותי וקולי בקצב שלכם‬</a:t>
             </a:r>
             <a:endParaRPr lang="he-IL" sz="1150" dirty="0"/>
           </a:p>
@@ -4464,7 +4464,7 @@
                 <a:ea typeface="Arial" pitchFamily="34" charset="-122"/>
                 <a:cs typeface="Arial" pitchFamily="34" charset="-120"/>
               </a:rPr>
-              <a:t>משחק לימודי</a:t>
+              <a:t>‫משחק לימודי‬</a:t>
             </a:r>
             <a:endParaRPr lang="he-IL" sz="1550" dirty="0"/>
           </a:p>
@@ -4503,7 +4503,7 @@
                 <a:ea typeface="Arial" pitchFamily="34" charset="-122"/>
                 <a:cs typeface="Arial" pitchFamily="34" charset="-120"/>
               </a:rPr>
-              <a:t>הופכים את החומר לחוויה אינטראקטיבית</a:t>
+              <a:t>‫הופכים את החומר לחוויה אינטראקטיבית‬</a:t>
             </a:r>
             <a:endParaRPr lang="he-IL" sz="1150" dirty="0"/>
           </a:p>
@@ -4613,7 +4613,7 @@
                 <a:ea typeface="Arial" pitchFamily="34" charset="-122"/>
                 <a:cs typeface="Arial" pitchFamily="34" charset="-120"/>
               </a:rPr>
-              <a:t>דגם תלת-ממדי</a:t>
+              <a:t>‫דגם תלת-ממדי‬</a:t>
             </a:r>
             <a:endParaRPr lang="he-IL" sz="1550" dirty="0"/>
           </a:p>
@@ -4652,7 +4652,7 @@
                 <a:ea typeface="Arial" pitchFamily="34" charset="-122"/>
                 <a:cs typeface="Arial" pitchFamily="34" charset="-120"/>
               </a:rPr>
-              <a:t>בונים DNA, תא או כרומוזום</a:t>
+              <a:t>‫בונים DNA, תא או כרומוזום‬</a:t>
             </a:r>
             <a:endParaRPr lang="he-IL" sz="1150" dirty="0"/>
           </a:p>
@@ -4762,7 +4762,7 @@
                 <a:ea typeface="Arial" pitchFamily="34" charset="-122"/>
                 <a:cs typeface="Arial" pitchFamily="34" charset="-120"/>
               </a:rPr>
-              <a:t>ציר זמן</a:t>
+              <a:t>‫ציר זמן‬</a:t>
             </a:r>
             <a:endParaRPr lang="he-IL" sz="1550" dirty="0"/>
           </a:p>
@@ -4801,7 +4801,7 @@
                 <a:ea typeface="Arial" pitchFamily="34" charset="-122"/>
                 <a:cs typeface="Arial" pitchFamily="34" charset="-120"/>
               </a:rPr>
-              <a:t>תגליות הגנטיקה לאורך השנים</a:t>
+              <a:t>‫תגליות הגנטיקה לאורך השנים‬</a:t>
             </a:r>
             <a:endParaRPr lang="he-IL" sz="1150" dirty="0"/>
           </a:p>
@@ -4911,7 +4911,7 @@
                 <a:ea typeface="Arial" pitchFamily="34" charset="-122"/>
                 <a:cs typeface="Arial" pitchFamily="34" charset="-120"/>
               </a:rPr>
-              <a:t>טבלת השוואה</a:t>
+              <a:t>‫טבלת השוואה‬</a:t>
             </a:r>
             <a:endParaRPr lang="he-IL" sz="1550" dirty="0"/>
           </a:p>
@@ -4950,7 +4950,7 @@
                 <a:ea typeface="Arial" pitchFamily="34" charset="-122"/>
                 <a:cs typeface="Arial" pitchFamily="34" charset="-120"/>
               </a:rPr>
-              <a:t>למשל: DNA מול RNA, דומיננטי מול רצסיבי</a:t>
+              <a:t>‫למשל: DNA מול RNA, דומיננטי מול רצסיבי‬</a:t>
             </a:r>
             <a:endParaRPr lang="he-IL" sz="1150" dirty="0"/>
           </a:p>
@@ -5011,7 +5011,7 @@
                 <a:ea typeface="Arial" pitchFamily="34" charset="-122"/>
                 <a:cs typeface="Arial" pitchFamily="34" charset="-120"/>
               </a:rPr>
-              <a:t>אפשר לעבוד לבד, בזוג או בקבוצה קטנה. לכל תוצר מצרפים קישור למקורות שבהם השתמשתם.</a:t>
+              <a:t>‫אפשר לעבוד לבד, בזוג או בקבוצה קטנה. לכל תוצר מצרפים קישור למקורות שבהם השתמשתם.‬</a:t>
             </a:r>
             <a:endParaRPr lang="he-IL" sz="1300" dirty="0"/>
           </a:p>
@@ -5121,7 +5121,7 @@
                 <a:ea typeface="Arial" pitchFamily="34" charset="-122"/>
                 <a:cs typeface="Arial" pitchFamily="34" charset="-120"/>
               </a:rPr>
-              <a:t>איך עובדים על התוצר?</a:t>
+              <a:t>‫איך עובדים על התוצר?‬</a:t>
             </a:r>
             <a:endParaRPr lang="he-IL" sz="3200" dirty="0"/>
           </a:p>
@@ -5228,7 +5228,7 @@
                 <a:ea typeface="Arial" pitchFamily="34" charset="-122"/>
                 <a:cs typeface="Arial" pitchFamily="34" charset="-120"/>
               </a:rPr>
-              <a:t>בוחרים</a:t>
+              <a:t>‫בוחרים‬</a:t>
             </a:r>
             <a:endParaRPr lang="he-IL" sz="1700" dirty="0"/>
           </a:p>
@@ -5267,7 +5267,7 @@
                 <a:ea typeface="Arial" pitchFamily="34" charset="-122"/>
                 <a:cs typeface="Arial" pitchFamily="34" charset="-120"/>
               </a:rPr>
-              <a:t>תוצר מלוח הבחירה שמתאים לחוזקות שלכם.</a:t>
+              <a:t>‫תוצר מלוח הבחירה שמתאים לחוזקות שלכם.‬</a:t>
             </a:r>
             <a:endParaRPr lang="he-IL" sz="1450" dirty="0"/>
           </a:p>
@@ -5374,7 +5374,7 @@
                 <a:ea typeface="Arial" pitchFamily="34" charset="-122"/>
                 <a:cs typeface="Arial" pitchFamily="34" charset="-120"/>
               </a:rPr>
-              <a:t>מתכננים</a:t>
+              <a:t>‫מתכננים‬</a:t>
             </a:r>
             <a:endParaRPr lang="he-IL" sz="1700" dirty="0"/>
           </a:p>
@@ -5413,7 +5413,7 @@
                 <a:ea typeface="Arial" pitchFamily="34" charset="-122"/>
                 <a:cs typeface="Arial" pitchFamily="34" charset="-120"/>
               </a:rPr>
-              <a:t>מגדירים מטרה, מחלקים את העבודה לשלבים וקובעים לוח זמנים.</a:t>
+              <a:t>‫מגדירים מטרה, מחלקים את העבודה לשלבים וקובעים לוח זמנים.‬</a:t>
             </a:r>
             <a:endParaRPr lang="he-IL" sz="1450" dirty="0"/>
           </a:p>
@@ -5520,7 +5520,7 @@
                 <a:ea typeface="Arial" pitchFamily="34" charset="-122"/>
                 <a:cs typeface="Arial" pitchFamily="34" charset="-120"/>
               </a:rPr>
-              <a:t>עובדים ובודקים</a:t>
+              <a:t>‫עובדים ובודקים‬</a:t>
             </a:r>
             <a:endParaRPr lang="he-IL" sz="1700" dirty="0"/>
           </a:p>
@@ -5559,7 +5559,7 @@
                 <a:ea typeface="Arial" pitchFamily="34" charset="-122"/>
                 <a:cs typeface="Arial" pitchFamily="34" charset="-120"/>
               </a:rPr>
-              <a:t>משווים את עצמכם למחוון תוך כדי העבודה, ומשנים כיוון אם צריך.</a:t>
+              <a:t>‫משווים את עצמכם למחוון תוך כדי העבודה, ומשנים כיוון אם צריך.‬</a:t>
             </a:r>
             <a:endParaRPr lang="he-IL" sz="1450" dirty="0"/>
           </a:p>
@@ -5666,7 +5666,7 @@
                 <a:ea typeface="Arial" pitchFamily="34" charset="-122"/>
                 <a:cs typeface="Arial" pitchFamily="34" charset="-120"/>
               </a:rPr>
-              <a:t>מציגים ומשתפים</a:t>
+              <a:t>‫מציגים ומשתפים‬</a:t>
             </a:r>
             <a:endParaRPr lang="he-IL" sz="1700" dirty="0"/>
           </a:p>
@@ -5705,7 +5705,7 @@
                 <a:ea typeface="Arial" pitchFamily="34" charset="-122"/>
                 <a:cs typeface="Arial" pitchFamily="34" charset="-120"/>
               </a:rPr>
-              <a:t>מציגים לכיתה, נותנים משוב לחברים ומקבלים משוב בחזרה.</a:t>
+              <a:t>‫מציגים לכיתה, נותנים משוב לחברים ומקבלים משוב בחזרה.‬</a:t>
             </a:r>
             <a:endParaRPr lang="he-IL" sz="1450" dirty="0"/>
           </a:p>
@@ -5744,7 +5744,7 @@
                 <a:ea typeface="Arial" pitchFamily="34" charset="-122"/>
                 <a:cs typeface="Arial" pitchFamily="34" charset="-120"/>
               </a:rPr>
-              <a:t>ובסוף הדרך, שאלה אחת לעצמכם: מה עבד לי טוב, ומה אעשה אחרת בפעם הבאה?</a:t>
+              <a:t>‫ובסוף הדרך, שאלה אחת לעצמכם: מה עבד לי טוב, ומה אעשה אחרת בפעם הבאה?‬</a:t>
             </a:r>
             <a:endParaRPr lang="he-IL" sz="1500" dirty="0"/>
           </a:p>
@@ -5854,7 +5854,7 @@
                 <a:ea typeface="Arial" pitchFamily="34" charset="-122"/>
                 <a:cs typeface="Arial" pitchFamily="34" charset="-120"/>
               </a:rPr>
-              <a:t>חכמים ברשת: מקורות ו-AI</a:t>
+              <a:t>‫חכמים ברשת: מקורות ו-AI‬</a:t>
             </a:r>
             <a:endParaRPr lang="he-IL" sz="3200" dirty="0"/>
           </a:p>
@@ -5964,7 +5964,7 @@
                 <a:ea typeface="Arial" pitchFamily="34" charset="-122"/>
                 <a:cs typeface="Arial" pitchFamily="34" charset="-120"/>
               </a:rPr>
-              <a:t>לפני שמשתמשים במידע</a:t>
+              <a:t>‫לפני שמשתמשים במידע‬</a:t>
             </a:r>
             <a:endParaRPr lang="he-IL" sz="1800" dirty="0"/>
           </a:p>
@@ -6047,7 +6047,7 @@
                 <a:ea typeface="Arial" pitchFamily="34" charset="-122"/>
                 <a:cs typeface="Arial" pitchFamily="34" charset="-120"/>
               </a:rPr>
-              <a:t>בודקים מי כתב אותו ומטעם איזה גוף.</a:t>
+              <a:t>‫בודקים מי כתב אותו ומטעם איזה גוף.‬</a:t>
             </a:r>
             <a:endParaRPr lang="he-IL" sz="1350" dirty="0"/>
           </a:p>
@@ -6130,7 +6130,7 @@
                 <a:ea typeface="Arial" pitchFamily="34" charset="-122"/>
                 <a:cs typeface="Arial" pitchFamily="34" charset="-120"/>
               </a:rPr>
-              <a:t>בודקים מתי הוא עודכן לאחרונה.</a:t>
+              <a:t>‫בודקים מתי הוא עודכן לאחרונה.‬</a:t>
             </a:r>
             <a:endParaRPr lang="he-IL" sz="1350" dirty="0"/>
           </a:p>
@@ -6213,7 +6213,7 @@
                 <a:ea typeface="Arial" pitchFamily="34" charset="-122"/>
                 <a:cs typeface="Arial" pitchFamily="34" charset="-120"/>
               </a:rPr>
-              <a:t>משווים: האם מקור נוסף אומר אותו דבר?</a:t>
+              <a:t>‫משווים: האם מקור נוסף אומר אותו דבר?‬</a:t>
             </a:r>
             <a:endParaRPr lang="he-IL" sz="1350" dirty="0"/>
           </a:p>
@@ -6296,7 +6296,7 @@
                 <a:ea typeface="Arial" pitchFamily="34" charset="-122"/>
                 <a:cs typeface="Arial" pitchFamily="34" charset="-120"/>
               </a:rPr>
-              <a:t>שומרים את הקישור ומצרפים אותו לתוצר.</a:t>
+              <a:t>‫שומרים את הקישור ומצרפים אותו לתוצר.‬</a:t>
             </a:r>
             <a:endParaRPr lang="he-IL" sz="1350" dirty="0"/>
           </a:p>
@@ -6406,7 +6406,7 @@
                 <a:ea typeface="Arial" pitchFamily="34" charset="-122"/>
                 <a:cs typeface="Arial" pitchFamily="34" charset="-120"/>
               </a:rPr>
-              <a:t>עובדים עם AI כמו מקצוענים</a:t>
+              <a:t>‫עובדים עם AI כמו מקצוענים‬</a:t>
             </a:r>
             <a:endParaRPr lang="he-IL" sz="1800" dirty="0"/>
           </a:p>
@@ -6489,7 +6489,7 @@
                 <a:ea typeface="Arial" pitchFamily="34" charset="-122"/>
                 <a:cs typeface="Arial" pitchFamily="34" charset="-120"/>
               </a:rPr>
-              <a:t>AI עוזר לרעיונות, לארגון המידע ולניסוח.</a:t>
+              <a:t>‫AI עוזר לרעיונות, לארגון המידע ולניסוח.‬</a:t>
             </a:r>
             <a:endParaRPr lang="he-IL" sz="1350" dirty="0"/>
           </a:p>
@@ -6572,7 +6572,7 @@
                 <a:ea typeface="Arial" pitchFamily="34" charset="-122"/>
                 <a:cs typeface="Arial" pitchFamily="34" charset="-120"/>
               </a:rPr>
-              <a:t>הוא לא מחליף את ההבנה שלכם.</a:t>
+              <a:t>‫הוא לא מחליף את ההבנה שלכם.‬</a:t>
             </a:r>
             <a:endParaRPr lang="he-IL" sz="1350" dirty="0"/>
           </a:p>
@@ -6655,7 +6655,7 @@
                 <a:ea typeface="Arial" pitchFamily="34" charset="-122"/>
                 <a:cs typeface="Arial" pitchFamily="34" charset="-120"/>
               </a:rPr>
-              <a:t>כל תשובה שלו בודקים מול מקור אמין.</a:t>
+              <a:t>‫כל תשובה שלו בודקים מול מקור אמין.‬</a:t>
             </a:r>
             <a:endParaRPr lang="he-IL" sz="1350" dirty="0"/>
           </a:p>
@@ -6738,7 +6738,7 @@
                 <a:ea typeface="Arial" pitchFamily="34" charset="-122"/>
                 <a:cs typeface="Arial" pitchFamily="34" charset="-120"/>
               </a:rPr>
-              <a:t>מספרים בתוצר במה בדיוק נעזרתם.</a:t>
+              <a:t>‫מספרים בתוצר במה בדיוק נעזרתם.‬</a:t>
             </a:r>
             <a:endParaRPr lang="he-IL" sz="1350" dirty="0"/>
           </a:p>
@@ -7734,7 +7734,7 @@
                 <a:ea typeface="Arial" pitchFamily="34" charset="-122"/>
                 <a:cs typeface="Arial" pitchFamily="34" charset="-120"/>
               </a:rPr>
-              <a:t>יוצאים לדרך!</a:t>
+              <a:t>‫יוצאים לדרך!‬</a:t>
             </a:r>
             <a:endParaRPr lang="he-IL" sz="4000" dirty="0"/>
           </a:p>
@@ -7826,7 +7826,7 @@
                   </a:extLst>
                 </a:hlinkClick>
               </a:rPr>
-              <a:t>צופים בטריילר בתחילת השיעור</a:t>
+              <a:t>‫צופים בטריילר בתחילת השיעור‬</a:t>
             </a:r>
             <a:endParaRPr lang="he-IL" sz="1900" dirty="0"/>
           </a:p>
@@ -7918,7 +7918,7 @@
                   </a:extLst>
                 </a:hlinkClick>
               </a:rPr>
-              <a:t>בוחרים תוצר מלוח הבחירה</a:t>
+              <a:t>‫בוחרים תוצר מלוח הבחירה‬</a:t>
             </a:r>
             <a:endParaRPr lang="he-IL" sz="1900" dirty="0"/>
           </a:p>
@@ -8001,7 +8001,7 @@
                 <a:ea typeface="Arial" pitchFamily="34" charset="-122"/>
                 <a:cs typeface="Arial" pitchFamily="34" charset="-120"/>
               </a:rPr>
-              <a:t>מתכננים שלבים ולוח זמנים</a:t>
+              <a:t>‫מתכננים שלבים ולוח זמנים‬</a:t>
             </a:r>
             <a:endParaRPr lang="he-IL" sz="1900" dirty="0"/>
           </a:p>
@@ -8084,7 +8084,7 @@
                 <a:ea typeface="Arial" pitchFamily="34" charset="-122"/>
                 <a:cs typeface="Arial" pitchFamily="34" charset="-120"/>
               </a:rPr>
-              <a:t>בודקים מקורות ומצרפים קישורים</a:t>
+              <a:t>‫בודקים מקורות ומצרפים קישורים‬</a:t>
             </a:r>
             <a:endParaRPr lang="he-IL" sz="1900" dirty="0"/>
           </a:p>
@@ -8167,7 +8167,7 @@
                 <a:ea typeface="Arial" pitchFamily="34" charset="-122"/>
                 <a:cs typeface="Arial" pitchFamily="34" charset="-120"/>
               </a:rPr>
-              <a:t>מציגים, משתפים ונהנים</a:t>
+              <a:t>‫מציגים, משתפים ונהנים‬</a:t>
             </a:r>
             <a:endParaRPr lang="he-IL" sz="1900" dirty="0"/>
           </a:p>
@@ -8206,7 +8206,7 @@
                 <a:ea typeface="Arial" pitchFamily="34" charset="-122"/>
                 <a:cs typeface="Arial" pitchFamily="34" charset="-120"/>
               </a:rPr>
-              <a:t>בהצלחה! אנחנו כבר סקרנים לראות מה תיצרו.</a:t>
+              <a:t>‫בהצלחה! אנחנו כבר סקרנים לראות מה תיצרו.‬</a:t>
             </a:r>
             <a:endParaRPr lang="he-IL" sz="1800" dirty="0"/>
           </a:p>
@@ -8316,7 +8316,7 @@
                 <a:ea typeface="Arial" pitchFamily="34" charset="-122"/>
                 <a:cs typeface="Arial" pitchFamily="34" charset="-120"/>
               </a:rPr>
-              <a:t>רשימת מקורות</a:t>
+              <a:t>‫רשימת מקורות‬</a:t>
             </a:r>
             <a:endParaRPr lang="he-IL" sz="3200" dirty="0"/>
           </a:p>
@@ -8355,7 +8355,7 @@
                 <a:ea typeface="Arial" pitchFamily="34" charset="-122"/>
                 <a:cs typeface="Arial" pitchFamily="34" charset="-120"/>
               </a:rPr>
-              <a:t>אייל, ל׳, והלוש-מנסקר, ע׳ (בפרסום). פרקטיקות הוראה מקדמות אסטרטגיות הכוונה עצמית בלמידה.</a:t>
+              <a:t>‫אייל, ל׳, והלוש-מנסקר, ע׳ (בפרסום). פרקטיקות הוראה מקדמות אסטרטגיות הכוונה עצמית בלמידה.‬</a:t>
             </a:r>
             <a:endParaRPr lang="he-IL" sz="1400" dirty="0"/>
           </a:p>
@@ -8394,7 +8394,7 @@
                 <a:ea typeface="Arial" pitchFamily="34" charset="-122"/>
                 <a:cs typeface="Arial" pitchFamily="34" charset="-120"/>
               </a:rPr>
-              <a:t>משרד החינוך. (2020). מצפן 2030: דמות הבוגר/ת והיערכות מערכת החינוך.</a:t>
+              <a:t>‫משרד החינוך. (2020). מצפן 2030: דמות הבוגר/ת והיערכות מערכת החינוך.‬</a:t>
             </a:r>
             <a:endParaRPr lang="he-IL" sz="1400" dirty="0"/>
           </a:p>
@@ -8567,7 +8567,7 @@
                 <a:ea typeface="Arial" pitchFamily="34" charset="-122"/>
                 <a:cs typeface="Arial" pitchFamily="34" charset="-120"/>
               </a:rPr>
-              <a:t>הטריילר ולוח הבחירה הוכנו על ידינו במסגרת היחידה.</a:t>
+              <a:t>‫הטריילר ולוח הבחירה הוכנו על ידינו במסגרת היחידה.‬</a:t>
             </a:r>
             <a:endParaRPr lang="he-IL" sz="1300" dirty="0"/>
           </a:p>
@@ -8677,7 +8677,7 @@
                 <a:ea typeface="Arial" pitchFamily="34" charset="-122"/>
                 <a:cs typeface="Arial" pitchFamily="34" charset="-120"/>
               </a:rPr>
-              <a:t>רגע לפני שמתחילים...</a:t>
+              <a:t>‫רגע לפני שמתחילים...‬</a:t>
             </a:r>
             <a:endParaRPr lang="he-IL" sz="3200" dirty="0"/>
           </a:p>
@@ -8716,7 +8716,7 @@
                 <a:ea typeface="Arial" pitchFamily="34" charset="-122"/>
                 <a:cs typeface="Arial" pitchFamily="34" charset="-120"/>
               </a:rPr>
-              <a:t>הכנו לכם טריילר קצר שמציג את מה שמחכה לכם ביחידה</a:t>
+              <a:t>‫הכנו לכם טריילר קצר שמציג את מה שמחכה לכם ביחידה‬</a:t>
             </a:r>
             <a:endParaRPr lang="he-IL" sz="1600" dirty="0"/>
           </a:p>
@@ -8841,7 +8841,7 @@
                   </a:extLst>
                 </a:hlinkClick>
               </a:rPr>
-              <a:t>לחצו כאן לצפייה בטריילר</a:t>
+              <a:t>‫לחצו כאן לצפייה בטריילר‬</a:t>
             </a:r>
             <a:endParaRPr lang="he-IL" sz="2000" dirty="0"/>
           </a:p>
@@ -8880,7 +8880,7 @@
                 <a:ea typeface="Arial" pitchFamily="34" charset="-122"/>
                 <a:cs typeface="Arial" pitchFamily="34" charset="-120"/>
               </a:rPr>
-              <a:t>צפו יחד בתחילת השיעור. אחרי הצפייה נדבר: מה סיקרן אתכם הכי הרבה?</a:t>
+              <a:t>‫צפו יחד בתחילת השיעור. אחרי הצפייה נדבר: מה סיקרן אתכם הכי הרבה?‬</a:t>
             </a:r>
             <a:endParaRPr lang="he-IL" sz="1500" dirty="0"/>
           </a:p>
@@ -8990,7 +8990,7 @@
                 <a:ea typeface="Arial" pitchFamily="34" charset="-122"/>
                 <a:cs typeface="Arial" pitchFamily="34" charset="-120"/>
               </a:rPr>
-              <a:t>מה מחכה לנו ביחידה?</a:t>
+              <a:t>‫מה מחכה לנו ביחידה?‬</a:t>
             </a:r>
             <a:endParaRPr lang="he-IL" sz="3200" dirty="0"/>
           </a:p>
@@ -9073,7 +9073,7 @@
                 <a:ea typeface="Arial" pitchFamily="34" charset="-122"/>
                 <a:cs typeface="Arial" pitchFamily="34" charset="-120"/>
               </a:rPr>
-              <a:t>נגלה מה זה DNA, איך הוא בנוי ואיפה הוא מסתתר בגוף.</a:t>
+              <a:t>‫נגלה מה זה DNA, איך הוא בנוי ואיפה הוא מסתתר בגוף.‬</a:t>
             </a:r>
             <a:endParaRPr lang="he-IL" sz="1800" dirty="0"/>
           </a:p>
@@ -9156,7 +9156,7 @@
                 <a:ea typeface="Arial" pitchFamily="34" charset="-122"/>
                 <a:cs typeface="Arial" pitchFamily="34" charset="-120"/>
               </a:rPr>
-              <a:t>נבין למה אנחנו דומים להורים שלנו: תורשה, גנים ותכונות.</a:t>
+              <a:t>‫נבין למה אנחנו דומים להורים שלנו: תורשה, גנים ותכונות.‬</a:t>
             </a:r>
             <a:endParaRPr lang="he-IL" sz="1800" dirty="0"/>
           </a:p>
@@ -9239,7 +9239,7 @@
                 <a:ea typeface="Arial" pitchFamily="34" charset="-122"/>
                 <a:cs typeface="Arial" pitchFamily="34" charset="-120"/>
               </a:rPr>
-              <a:t>נכיר מוטציות והנדסה גנטית, ונראה מה הן עושות בעולם האמיתי.</a:t>
+              <a:t>‫נכיר מוטציות והנדסה גנטית, ונראה מה הן עושות בעולם האמיתי.‬</a:t>
             </a:r>
             <a:endParaRPr lang="he-IL" sz="1800" dirty="0"/>
           </a:p>
@@ -9322,7 +9322,7 @@
                 <a:ea typeface="Arial" pitchFamily="34" charset="-122"/>
                 <a:cs typeface="Arial" pitchFamily="34" charset="-120"/>
               </a:rPr>
-              <a:t>ובסוף: אתם בוחרים איך להציג את מה שלמדתם, מתוך לוח בחירה.</a:t>
+              <a:t>‫ובסוף: אתם בוחרים איך להציג את מה שלמדתם, מתוך לוח בחירה.‬</a:t>
             </a:r>
             <a:endParaRPr lang="he-IL" sz="1800" dirty="0"/>
           </a:p>
@@ -10260,7 +10260,7 @@
                   </a:extLst>
                 </a:hlinkClick>
               </a:rPr>
-              <a:t>קפיצה ישירה ללוח הבחירה</a:t>
+              <a:t>‫קפיצה ישירה ללוח הבחירה‬</a:t>
             </a:r>
             <a:endParaRPr lang="he-IL" sz="1400" dirty="0"/>
           </a:p>
@@ -10370,7 +10370,7 @@
                 <a:ea typeface="Arial" pitchFamily="34" charset="-122"/>
                 <a:cs typeface="Arial" pitchFamily="34" charset="-120"/>
               </a:rPr>
-              <a:t>מה זה בכלל גנטיקה?</a:t>
+              <a:t>‫מה זה בכלל גנטיקה?‬</a:t>
             </a:r>
             <a:endParaRPr lang="he-IL" sz="3200" dirty="0"/>
           </a:p>
@@ -10480,7 +10480,7 @@
                 <a:ea typeface="Arial" pitchFamily="34" charset="-122"/>
                 <a:cs typeface="Arial" pitchFamily="34" charset="-120"/>
               </a:rPr>
-              <a:t>למה יש לך צבע עיניים</a:t>
+              <a:t>‫למה יש לך צבע עיניים‬</a:t>
             </a:r>
             <a:endParaRPr lang="he-IL" sz="1500" dirty="0"/>
           </a:p>
@@ -10497,7 +10497,7 @@
                 <a:ea typeface="Arial" pitchFamily="34" charset="-122"/>
                 <a:cs typeface="Arial" pitchFamily="34" charset="-120"/>
               </a:rPr>
-              <a:t>כמו של אמא?</a:t>
+              <a:t>‫כמו של אמא?‬</a:t>
             </a:r>
             <a:endParaRPr lang="he-IL" sz="1500" dirty="0"/>
           </a:p>
@@ -10607,7 +10607,7 @@
                 <a:ea typeface="Arial" pitchFamily="34" charset="-122"/>
                 <a:cs typeface="Arial" pitchFamily="34" charset="-120"/>
               </a:rPr>
-              <a:t>למה אחים דומים,</a:t>
+              <a:t>‫למה אחים דומים,‬</a:t>
             </a:r>
             <a:endParaRPr lang="he-IL" sz="1500" dirty="0"/>
           </a:p>
@@ -10624,7 +10624,7 @@
                 <a:ea typeface="Arial" pitchFamily="34" charset="-122"/>
                 <a:cs typeface="Arial" pitchFamily="34" charset="-120"/>
               </a:rPr>
-              <a:t>אבל אף פעם לא זהים?</a:t>
+              <a:t>‫אבל אף פעם לא זהים?‬</a:t>
             </a:r>
             <a:endParaRPr lang="he-IL" sz="1500" dirty="0"/>
           </a:p>
@@ -10734,7 +10734,7 @@
                 <a:ea typeface="Arial" pitchFamily="34" charset="-122"/>
                 <a:cs typeface="Arial" pitchFamily="34" charset="-120"/>
               </a:rPr>
-              <a:t>איך מזהים אדם</a:t>
+              <a:t>‫איך מזהים אדם‬</a:t>
             </a:r>
             <a:endParaRPr lang="he-IL" sz="1500" dirty="0"/>
           </a:p>
@@ -10751,7 +10751,7 @@
                 <a:ea typeface="Arial" pitchFamily="34" charset="-122"/>
                 <a:cs typeface="Arial" pitchFamily="34" charset="-120"/>
               </a:rPr>
-              <a:t>לפי שערה אחת?</a:t>
+              <a:t>‫לפי שערה אחת?‬</a:t>
             </a:r>
             <a:endParaRPr lang="he-IL" sz="1500" dirty="0"/>
           </a:p>
@@ -10856,7 +10856,7 @@
                 <a:ea typeface="Arial" pitchFamily="34" charset="-122"/>
                 <a:cs typeface="Arial" pitchFamily="34" charset="-120"/>
               </a:rPr>
-              <a:t>גנטיקה היא תחום במדע שחוקר איך תכונות עוברות בתורשה, מהורים לילדים.</a:t>
+              <a:t>‫גנטיקה היא תחום במדע שחוקר איך תכונות עוברות בתורשה, מהורים לילדים.‬</a:t>
             </a:r>
             <a:endParaRPr lang="he-IL" sz="1800" dirty="0"/>
           </a:p>
@@ -10895,7 +10895,7 @@
                 <a:ea typeface="Arial" pitchFamily="34" charset="-122"/>
                 <a:cs typeface="Arial" pitchFamily="34" charset="-120"/>
               </a:rPr>
-              <a:t>התשובות לכל השאלות האלה מסתתרות במולקולה קטנה אחת: DNA. בואו נכיר אותה.</a:t>
+              <a:t>‫התשובות לכל השאלות האלה מסתתרות במולקולה קטנה אחת: DNA. בואו נכיר אותה.‬</a:t>
             </a:r>
             <a:endParaRPr lang="he-IL" sz="1600" dirty="0"/>
           </a:p>
@@ -11005,7 +11005,7 @@
                 <a:ea typeface="Arial" pitchFamily="34" charset="-122"/>
                 <a:cs typeface="Arial" pitchFamily="34" charset="-120"/>
               </a:rPr>
-              <a:t>איפה מסתתר הצופן?</a:t>
+              <a:t>‫איפה מסתתר הצופן?‬</a:t>
             </a:r>
             <a:endParaRPr lang="he-IL" sz="3200" dirty="0"/>
           </a:p>
@@ -11044,7 +11044,7 @@
                 <a:ea typeface="Arial" pitchFamily="34" charset="-122"/>
                 <a:cs typeface="Arial" pitchFamily="34" charset="-120"/>
               </a:rPr>
-              <a:t>מתקרבים פנימה, שלב אחרי שלב</a:t>
+              <a:t>‫מתקרבים פנימה, שלב אחרי שלב‬</a:t>
             </a:r>
             <a:endParaRPr lang="he-IL" sz="1600" dirty="0"/>
           </a:p>
@@ -11127,7 +11127,7 @@
                 <a:ea typeface="Arial" pitchFamily="34" charset="-122"/>
                 <a:cs typeface="Arial" pitchFamily="34" charset="-120"/>
               </a:rPr>
-              <a:t>הגוף</a:t>
+              <a:t>‫הגוף‬</a:t>
             </a:r>
             <a:endParaRPr lang="he-IL" sz="1600" dirty="0"/>
           </a:p>
@@ -11166,7 +11166,7 @@
                 <a:ea typeface="Arial" pitchFamily="34" charset="-122"/>
                 <a:cs typeface="Arial" pitchFamily="34" charset="-120"/>
               </a:rPr>
-              <a:t>טריליוני תאים</a:t>
+              <a:t>‫טריליוני תאים‬</a:t>
             </a:r>
             <a:endParaRPr lang="he-IL" sz="1150" dirty="0"/>
           </a:p>
@@ -11275,7 +11275,7 @@
                 <a:ea typeface="Arial" pitchFamily="34" charset="-122"/>
                 <a:cs typeface="Arial" pitchFamily="34" charset="-120"/>
               </a:rPr>
-              <a:t>התא</a:t>
+              <a:t>‫התא‬</a:t>
             </a:r>
             <a:endParaRPr lang="he-IL" sz="1600" dirty="0"/>
           </a:p>
@@ -11314,7 +11314,7 @@
                 <a:ea typeface="Arial" pitchFamily="34" charset="-122"/>
                 <a:cs typeface="Arial" pitchFamily="34" charset="-120"/>
               </a:rPr>
-              <a:t>יחידת החיים</a:t>
+              <a:t>‫יחידת החיים‬</a:t>
             </a:r>
             <a:endParaRPr lang="he-IL" sz="1150" dirty="0"/>
           </a:p>
@@ -11423,7 +11423,7 @@
                 <a:ea typeface="Arial" pitchFamily="34" charset="-122"/>
                 <a:cs typeface="Arial" pitchFamily="34" charset="-120"/>
               </a:rPr>
-              <a:t>הגרעין</a:t>
+              <a:t>‫הגרעין‬</a:t>
             </a:r>
             <a:endParaRPr lang="he-IL" sz="1600" dirty="0"/>
           </a:p>
@@ -11462,7 +11462,7 @@
                 <a:ea typeface="Arial" pitchFamily="34" charset="-122"/>
                 <a:cs typeface="Arial" pitchFamily="34" charset="-120"/>
               </a:rPr>
-              <a:t>מרכז הבקרה</a:t>
+              <a:t>‫מרכז הבקרה‬</a:t>
             </a:r>
             <a:endParaRPr lang="he-IL" sz="1150" dirty="0"/>
           </a:p>
@@ -11571,7 +11571,7 @@
                 <a:ea typeface="Arial" pitchFamily="34" charset="-122"/>
                 <a:cs typeface="Arial" pitchFamily="34" charset="-120"/>
               </a:rPr>
-              <a:t>כרומוזום</a:t>
+              <a:t>‫כרומוזום‬</a:t>
             </a:r>
             <a:endParaRPr lang="he-IL" sz="1600" dirty="0"/>
           </a:p>
@@ -11610,7 +11610,7 @@
                 <a:ea typeface="Arial" pitchFamily="34" charset="-122"/>
                 <a:cs typeface="Arial" pitchFamily="34" charset="-120"/>
               </a:rPr>
-              <a:t>46 בכל תא</a:t>
+              <a:t>‫46 בכל תא‬</a:t>
             </a:r>
             <a:endParaRPr lang="he-IL" sz="1150" dirty="0"/>
           </a:p>
@@ -11719,7 +11719,7 @@
                 <a:ea typeface="Arial" pitchFamily="34" charset="-122"/>
                 <a:cs typeface="Arial" pitchFamily="34" charset="-120"/>
               </a:rPr>
-              <a:t>DNA</a:t>
+              <a:t>‫DNA‬</a:t>
             </a:r>
             <a:endParaRPr lang="he-IL" sz="1600" dirty="0"/>
           </a:p>
@@ -11758,7 +11758,7 @@
                 <a:ea typeface="Arial" pitchFamily="34" charset="-122"/>
                 <a:cs typeface="Arial" pitchFamily="34" charset="-120"/>
               </a:rPr>
-              <a:t>הסולם המפותל</a:t>
+              <a:t>‫הסולם המפותל‬</a:t>
             </a:r>
             <a:endParaRPr lang="he-IL" sz="1150" dirty="0"/>
           </a:p>
@@ -11867,7 +11867,7 @@
                 <a:ea typeface="Arial" pitchFamily="34" charset="-122"/>
                 <a:cs typeface="Arial" pitchFamily="34" charset="-120"/>
               </a:rPr>
-              <a:t>גן</a:t>
+              <a:t>‫גן‬</a:t>
             </a:r>
             <a:endParaRPr lang="he-IL" sz="1600" dirty="0"/>
           </a:p>
@@ -11906,7 +11906,7 @@
                 <a:ea typeface="Arial" pitchFamily="34" charset="-122"/>
                 <a:cs typeface="Arial" pitchFamily="34" charset="-120"/>
               </a:rPr>
-              <a:t>הוראה לתכונה אחת</a:t>
+              <a:t>‫הוראה לתכונה אחת‬</a:t>
             </a:r>
             <a:endParaRPr lang="he-IL" sz="1150" dirty="0"/>
           </a:p>
@@ -11945,7 +11945,7 @@
                 <a:ea typeface="Arial" pitchFamily="34" charset="-122"/>
                 <a:cs typeface="Arial" pitchFamily="34" charset="-120"/>
               </a:rPr>
-              <a:t>בתוך כל תא בגוף שלכם נמצא עותק מלא של כל ההוראות. מדהים, לא?</a:t>
+              <a:t>‫בתוך כל תא בגוף שלכם נמצא עותק מלא של כל ההוראות. מדהים, לא?‬</a:t>
             </a:r>
             <a:endParaRPr lang="he-IL" sz="1500" dirty="0"/>
           </a:p>
@@ -12055,7 +12055,7 @@
                 <a:ea typeface="Arial" pitchFamily="34" charset="-122"/>
                 <a:cs typeface="Arial" pitchFamily="34" charset="-120"/>
               </a:rPr>
-              <a:t>שפת ה-DNA: ארבע אותיות בלבד</a:t>
+              <a:t>‫שפת ה-DNA: ארבע אותיות בלבד‬</a:t>
             </a:r>
             <a:endParaRPr lang="he-IL" sz="3200" dirty="0"/>
           </a:p>
@@ -12094,7 +12094,7 @@
                 <a:ea typeface="Arial" pitchFamily="34" charset="-122"/>
                 <a:cs typeface="Arial" pitchFamily="34" charset="-120"/>
               </a:rPr>
-              <a:t>ה-DNA נראה כמו סולם מפותל. כל שלב בסולם בנוי מזוג "אותיות" כימיות.</a:t>
+              <a:t>‫ה-DNA נראה כמו סולם מפותל. כל שלב בסולם בנוי מזוג "אותיות" כימיות.‬</a:t>
             </a:r>
             <a:endParaRPr lang="he-IL" sz="1700" dirty="0"/>
           </a:p>
@@ -12133,7 +12133,7 @@
                 <a:ea typeface="Arial" pitchFamily="34" charset="-122"/>
                 <a:cs typeface="Arial" pitchFamily="34" charset="-120"/>
               </a:rPr>
-              <a:t>יש רק ארבע אותיות: A, T, G, C. הסדר שלהן הוא הצופן, וכולו יחד הוא ספר הוראות שלם לבניית הגוף ולהפעלתו.</a:t>
+              <a:t>‫יש רק ארבע אותיות: A, T, G, C. הסדר שלהן הוא הצופן, וכולו יחד הוא ספר הוראות שלם לבניית הגוף ולהפעלתו.‬</a:t>
             </a:r>
             <a:endParaRPr lang="he-IL" sz="1700" dirty="0"/>
           </a:p>
@@ -12172,7 +12172,7 @@
                 <a:ea typeface="Arial" pitchFamily="34" charset="-122"/>
                 <a:cs typeface="Arial" pitchFamily="34" charset="-120"/>
               </a:rPr>
-              <a:t>חוק הזיווג: A מתחברת תמיד אל T, ‏ו-G מתחברת תמיד אל C.</a:t>
+              <a:t>‫חוק הזיווג: A מתחברת תמיד אל T, ‏ו-G מתחברת תמיד אל C.‬</a:t>
             </a:r>
             <a:endParaRPr lang="he-IL" sz="1700" dirty="0"/>
           </a:p>
@@ -12277,7 +12277,7 @@
                 <a:ea typeface="Arial" pitchFamily="34" charset="-122"/>
                 <a:cs typeface="Arial" pitchFamily="34" charset="-120"/>
               </a:rPr>
-              <a:t>ידעתם? אם מותחים את ה-DNA שבתא אחד בלבד, מקבלים חוט באורך של כ-2 מטרים!</a:t>
+              <a:t>‫ידעתם? אם מותחים את ה-DNA שבתא אחד בלבד, מקבלים חוט באורך של כ-2 מטרים!‬</a:t>
             </a:r>
             <a:endParaRPr lang="he-IL" sz="1450" dirty="0"/>
           </a:p>
@@ -12839,7 +12839,7 @@
                 <a:ea typeface="Arial" pitchFamily="34" charset="-122"/>
                 <a:cs typeface="Arial" pitchFamily="34" charset="-120"/>
               </a:rPr>
-              <a:t>DNA מול RNA: מה ההבדל?</a:t>
+              <a:t>‫DNA מול RNA: מה ההבדל?‬</a:t>
             </a:r>
             <a:endParaRPr lang="he-IL" sz="3200" dirty="0"/>
           </a:p>
@@ -13010,7 +13010,7 @@
                 <a:ea typeface="Arial" pitchFamily="34" charset="-122"/>
                 <a:cs typeface="Arial" pitchFamily="34" charset="-120"/>
               </a:rPr>
-              <a:t>שני גדילים, בצורת סולם מפותל</a:t>
+              <a:t>‫שני גדילים, בצורת סולם מפותל‬</a:t>
             </a:r>
             <a:endParaRPr lang="he-IL" sz="1500" dirty="0"/>
           </a:p>
@@ -13049,7 +13049,7 @@
                 <a:ea typeface="Arial" pitchFamily="34" charset="-122"/>
                 <a:cs typeface="Arial" pitchFamily="34" charset="-120"/>
               </a:rPr>
-              <a:t>נשאר בתוך הגרעין</a:t>
+              <a:t>‫נשאר בתוך הגרעין‬</a:t>
             </a:r>
             <a:endParaRPr lang="he-IL" sz="1500" dirty="0"/>
           </a:p>
@@ -13088,7 +13088,7 @@
                 <a:ea typeface="Arial" pitchFamily="34" charset="-122"/>
                 <a:cs typeface="Arial" pitchFamily="34" charset="-120"/>
               </a:rPr>
-              <a:t>שומר את כל המידע לאורך זמן</a:t>
+              <a:t>‫שומר את כל המידע לאורך זמן‬</a:t>
             </a:r>
             <a:endParaRPr lang="he-IL" sz="1500" dirty="0"/>
           </a:p>
@@ -13127,7 +13127,7 @@
                 <a:ea typeface="Arial" pitchFamily="34" charset="-122"/>
                 <a:cs typeface="Arial" pitchFamily="34" charset="-120"/>
               </a:rPr>
-              <a:t>האותיות שלו: A T G C</a:t>
+              <a:t>‫האותיות שלו: A T G C‬</a:t>
             </a:r>
             <a:endParaRPr lang="he-IL" sz="1500" dirty="0"/>
           </a:p>
@@ -13298,7 +13298,7 @@
                 <a:ea typeface="Arial" pitchFamily="34" charset="-122"/>
                 <a:cs typeface="Arial" pitchFamily="34" charset="-120"/>
               </a:rPr>
-              <a:t>גדיל אחד בלבד</a:t>
+              <a:t>‫גדיל אחד בלבד‬</a:t>
             </a:r>
             <a:endParaRPr lang="he-IL" sz="1500" dirty="0"/>
           </a:p>
@@ -13337,7 +13337,7 @@
                 <a:ea typeface="Arial" pitchFamily="34" charset="-122"/>
                 <a:cs typeface="Arial" pitchFamily="34" charset="-120"/>
               </a:rPr>
-              <a:t>יוצא מהגרעין אל התא</a:t>
+              <a:t>‫יוצא מהגרעין אל התא‬</a:t>
             </a:r>
             <a:endParaRPr lang="he-IL" sz="1500" dirty="0"/>
           </a:p>
@@ -13376,7 +13376,7 @@
                 <a:ea typeface="Arial" pitchFamily="34" charset="-122"/>
                 <a:cs typeface="Arial" pitchFamily="34" charset="-120"/>
               </a:rPr>
-              <a:t>שליח: מעתיק הוראה ומעביר הלאה</a:t>
+              <a:t>‫שליח: מעתיק הוראה ומעביר הלאה‬</a:t>
             </a:r>
             <a:endParaRPr lang="he-IL" sz="1500" dirty="0"/>
           </a:p>
@@ -13415,7 +13415,7 @@
                 <a:ea typeface="Arial" pitchFamily="34" charset="-122"/>
                 <a:cs typeface="Arial" pitchFamily="34" charset="-120"/>
               </a:rPr>
-              <a:t>במקום T יש לו U</a:t>
+              <a:t>‫במקום T יש לו U‬</a:t>
             </a:r>
             <a:endParaRPr lang="he-IL" sz="1500" dirty="0"/>
           </a:p>
@@ -13476,7 +13476,7 @@
                 <a:ea typeface="Arial" pitchFamily="34" charset="-122"/>
                 <a:cs typeface="Arial" pitchFamily="34" charset="-120"/>
               </a:rPr>
-              <a:t>דרך קלה לזכור: ה-DNA הוא הספרייה, וה-RNA הוא העותק המצולם של דף אחד שיוצא ממנה.</a:t>
+              <a:t>‫דרך קלה לזכור: ה-DNA הוא הספרייה, וה-RNA הוא העותק המצולם של דף אחד שיוצא ממנה.‬</a:t>
             </a:r>
             <a:endParaRPr lang="he-IL" sz="1500" dirty="0"/>
           </a:p>
@@ -13586,7 +13586,7 @@
                 <a:ea typeface="Arial" pitchFamily="34" charset="-122"/>
                 <a:cs typeface="Arial" pitchFamily="34" charset="-120"/>
               </a:rPr>
-              <a:t>תכונה חזקה, תכונה שקטה</a:t>
+              <a:t>‫תכונה חזקה, תכונה שקטה‬</a:t>
             </a:r>
             <a:endParaRPr lang="he-IL" sz="3200" dirty="0"/>
           </a:p>
@@ -13625,7 +13625,7 @@
                 <a:ea typeface="Arial" pitchFamily="34" charset="-122"/>
                 <a:cs typeface="Arial" pitchFamily="34" charset="-120"/>
               </a:rPr>
-              <a:t>כל תכונה מגיעה בשני עותקים: אחד מאבא ואחד מאמא</a:t>
+              <a:t>‫כל תכונה מגיעה בשני עותקים: אחד מאבא ואחד מאמא‬</a:t>
             </a:r>
             <a:endParaRPr lang="he-IL" sz="1600" dirty="0"/>
           </a:p>
@@ -13713,7 +13713,7 @@
                 <a:ea typeface="Arial" pitchFamily="34" charset="-122"/>
                 <a:cs typeface="Arial" pitchFamily="34" charset="-120"/>
               </a:rPr>
-              <a:t>תכונה דומיננטית ("חזקה")</a:t>
+              <a:t>‫תכונה דומיננטית ("חזקה")‬</a:t>
             </a:r>
             <a:endParaRPr lang="en-US" sz="1900" dirty="0"/>
           </a:p>
@@ -13752,7 +13752,7 @@
                 <a:ea typeface="Arial" pitchFamily="34" charset="-122"/>
                 <a:cs typeface="Arial" pitchFamily="34" charset="-120"/>
               </a:rPr>
-              <a:t>מספיק עותק אחד שלה כדי שהיא תופיע אצלכם.</a:t>
+              <a:t>‫מספיק עותק אחד שלה כדי שהיא תופיע אצלכם.‬</a:t>
             </a:r>
             <a:endParaRPr lang="he-IL" sz="1550" dirty="0"/>
           </a:p>
@@ -13791,7 +13791,7 @@
                 <a:ea typeface="Arial" pitchFamily="34" charset="-122"/>
                 <a:cs typeface="Arial" pitchFamily="34" charset="-120"/>
               </a:rPr>
-              <a:t>דוגמה: עיניים חומות.</a:t>
+              <a:t>‫דוגמה: עיניים חומות.‬</a:t>
             </a:r>
             <a:endParaRPr lang="he-IL" sz="1450" dirty="0"/>
           </a:p>
@@ -13879,7 +13879,7 @@
                 <a:ea typeface="Arial" pitchFamily="34" charset="-122"/>
                 <a:cs typeface="Arial" pitchFamily="34" charset="-120"/>
               </a:rPr>
-              <a:t>תכונה רצסיבית ("שקטה")</a:t>
+              <a:t>‫תכונה רצסיבית ("שקטה")‬</a:t>
             </a:r>
             <a:endParaRPr lang="en-US" sz="1900" dirty="0"/>
           </a:p>
@@ -13918,7 +13918,7 @@
                 <a:ea typeface="Arial" pitchFamily="34" charset="-122"/>
                 <a:cs typeface="Arial" pitchFamily="34" charset="-120"/>
               </a:rPr>
-              <a:t>מופיעה רק כששני העותקים שקיבלתם הם שלה.</a:t>
+              <a:t>‫מופיעה רק כששני העותקים שקיבלתם הם שלה.‬</a:t>
             </a:r>
             <a:endParaRPr lang="he-IL" sz="1550" dirty="0"/>
           </a:p>
@@ -13957,7 +13957,7 @@
                 <a:ea typeface="Arial" pitchFamily="34" charset="-122"/>
                 <a:cs typeface="Arial" pitchFamily="34" charset="-120"/>
               </a:rPr>
-              <a:t>דוגמה: עיניים כחולות.</a:t>
+              <a:t>‫דוגמה: עיניים כחולות.‬</a:t>
             </a:r>
             <a:endParaRPr lang="he-IL" sz="1450" dirty="0"/>
           </a:p>
@@ -14062,7 +14062,7 @@
                 <a:ea typeface="Arial" pitchFamily="34" charset="-122"/>
                 <a:cs typeface="Arial" pitchFamily="34" charset="-120"/>
               </a:rPr>
-              <a:t>ולכן: שני הורים עם עיניים חומות יכולים לקבל ילד עם עיניים כחולות. לכל אחד מהם היה עותק "שקט", ושניהם העבירו אותו הלאה.</a:t>
+              <a:t>‫ולכן: שני הורים עם עיניים חומות יכולים לקבל ילד עם עיניים כחולות. לכל אחד מהם היה עותק "שקט", ושניהם העבירו אותו הלאה.‬</a:t>
             </a:r>
             <a:endParaRPr lang="he-IL" sz="1500" dirty="0"/>
           </a:p>
@@ -14172,7 +14172,7 @@
                 <a:ea typeface="Arial" pitchFamily="34" charset="-122"/>
                 <a:cs typeface="Arial" pitchFamily="34" charset="-120"/>
               </a:rPr>
-              <a:t>מוטציות: שינוי בצופן</a:t>
+              <a:t>‫מוטציות: שינוי בצופן‬</a:t>
             </a:r>
             <a:endParaRPr lang="he-IL" sz="3200" dirty="0"/>
           </a:p>
@@ -14211,7 +14211,7 @@
                 <a:ea typeface="Arial" pitchFamily="34" charset="-122"/>
                 <a:cs typeface="Arial" pitchFamily="34" charset="-120"/>
               </a:rPr>
-              <a:t>שינוי קטן ברצף האותיות של ה-DNA, כמו שגיאת הקלדה בספר ההוראות</a:t>
+              <a:t>‫שינוי קטן ברצף האותיות של ה-DNA, כמו שגיאת הקלדה בספר ההוראות‬</a:t>
             </a:r>
             <a:endParaRPr lang="he-IL" sz="1600" dirty="0"/>
           </a:p>
@@ -14321,7 +14321,7 @@
                 <a:ea typeface="Arial" pitchFamily="34" charset="-122"/>
                 <a:cs typeface="Arial" pitchFamily="34" charset="-120"/>
               </a:rPr>
-              <a:t>לרוב: לא קורה כלום</a:t>
+              <a:t>‫לרוב: לא קורה כלום‬</a:t>
             </a:r>
             <a:endParaRPr lang="he-IL" sz="1600" dirty="0"/>
           </a:p>
@@ -14360,7 +14360,7 @@
                 <a:ea typeface="Arial" pitchFamily="34" charset="-122"/>
                 <a:cs typeface="Arial" pitchFamily="34" charset="-120"/>
               </a:rPr>
-              <a:t>רוב המוטציות קטנות ולא מרגישים אותן בכלל.</a:t>
+              <a:t>‫רוב המוטציות קטנות ולא מרגישים אותן בכלל.‬</a:t>
             </a:r>
             <a:endParaRPr lang="he-IL" sz="1350" dirty="0"/>
           </a:p>
@@ -14470,7 +14470,7 @@
                 <a:ea typeface="Arial" pitchFamily="34" charset="-122"/>
                 <a:cs typeface="Arial" pitchFamily="34" charset="-120"/>
               </a:rPr>
-              <a:t>לפעמים: מזיקה</a:t>
+              <a:t>‫לפעמים: מזיקה‬</a:t>
             </a:r>
             <a:endParaRPr lang="he-IL" sz="1600" dirty="0"/>
           </a:p>
@@ -14509,7 +14509,7 @@
                 <a:ea typeface="Arial" pitchFamily="34" charset="-122"/>
                 <a:cs typeface="Arial" pitchFamily="34" charset="-120"/>
               </a:rPr>
-              <a:t>ההוראה משתבשת, וזה עלול לגרום למחלה.</a:t>
+              <a:t>‫ההוראה משתבשת, וזה עלול לגרום למחלה.‬</a:t>
             </a:r>
             <a:endParaRPr lang="he-IL" sz="1350" dirty="0"/>
           </a:p>
@@ -14619,7 +14619,7 @@
                 <a:ea typeface="Arial" pitchFamily="34" charset="-122"/>
                 <a:cs typeface="Arial" pitchFamily="34" charset="-120"/>
               </a:rPr>
-              <a:t>ולפעמים: דווקא מועילה</a:t>
+              <a:t>‫ולפעמים: דווקא מועילה‬</a:t>
             </a:r>
             <a:endParaRPr lang="he-IL" sz="1600" dirty="0"/>
           </a:p>
@@ -14658,7 +14658,7 @@
                 <a:ea typeface="Arial" pitchFamily="34" charset="-122"/>
                 <a:cs typeface="Arial" pitchFamily="34" charset="-120"/>
               </a:rPr>
-              <a:t>תכונה חדשה שעוזרת להסתדר טוב יותר בסביבה.</a:t>
+              <a:t>‫תכונה חדשה שעוזרת להסתדר טוב יותר בסביבה.‬</a:t>
             </a:r>
             <a:endParaRPr lang="he-IL" sz="1350" dirty="0"/>
           </a:p>
@@ -14719,7 +14719,7 @@
                 <a:ea typeface="Arial" pitchFamily="34" charset="-122"/>
                 <a:cs typeface="Arial" pitchFamily="34" charset="-120"/>
               </a:rPr>
-              <a:t>עובדה מגניבה: צבע העיניים הכחול התחיל כנראה ממוטציה אחת אצל אדם אחד, לפני אלפי שנים. כל כחולי העיניים בעולם ירשו אותה ממנו.</a:t>
+              <a:t>‫עובדה מגניבה: צבע העיניים הכחול התחיל כנראה ממוטציה אחת אצל אדם אחד, לפני אלפי שנים. כל כחולי העיניים בעולם ירשו אותה ממנו.‬</a:t>
             </a:r>
             <a:endParaRPr lang="he-IL" sz="1450" dirty="0"/>
           </a:p>

</xml_diff>